<commit_message>
Update case 5 usability results
</commit_message>
<xml_diff>
--- a/materials/ПП1_Презентация_кейс_5_Дружба_Notes.pptx
+++ b/materials/ПП1_Презентация_кейс_5_Дружба_Notes.pptx
@@ -2,18 +2,18 @@
 <file path=ppt/presentation.xml><?xml version="1.0" encoding="utf-8"?>
 <p:presentation xmlns:p="http://schemas.openxmlformats.org/presentationml/2006/main">
   <p:sldMasterIdLst>
-    <p:sldMasterId xmlns:r="http://schemas.openxmlformats.org/officeDocument/2006/relationships" id="2147483648" r:id="Rbd182e4e4b1c4c27"/>
+    <p:sldMasterId xmlns:r="http://schemas.openxmlformats.org/officeDocument/2006/relationships" id="2147483648" r:id="R87857e36a5e54bc2"/>
   </p:sldMasterIdLst>
   <p:notesMasterIdLst>
-    <p:notesMasterId xmlns:r="http://schemas.openxmlformats.org/officeDocument/2006/relationships" r:id="Re7637245b26f4df1"/>
+    <p:notesMasterId xmlns:r="http://schemas.openxmlformats.org/officeDocument/2006/relationships" r:id="R0ef1535f5b374bbf"/>
   </p:notesMasterIdLst>
   <p:sldIdLst>
-    <p:sldId xmlns:r="http://schemas.openxmlformats.org/officeDocument/2006/relationships" id="256" r:id="R9a76ad3af5434013"/>
-    <p:sldId xmlns:r="http://schemas.openxmlformats.org/officeDocument/2006/relationships" id="257" r:id="Rc2f6402af92a40a9"/>
-    <p:sldId xmlns:r="http://schemas.openxmlformats.org/officeDocument/2006/relationships" id="258" r:id="R4308a8ecb15941ee"/>
-    <p:sldId xmlns:r="http://schemas.openxmlformats.org/officeDocument/2006/relationships" id="259" r:id="Rb36bc9a762bf4fff"/>
-    <p:sldId xmlns:r="http://schemas.openxmlformats.org/officeDocument/2006/relationships" id="260" r:id="R0e1bc54cad1a46b0"/>
-    <p:sldId xmlns:r="http://schemas.openxmlformats.org/officeDocument/2006/relationships" id="261" r:id="R9d2dca7c61b44b74"/>
+    <p:sldId xmlns:r="http://schemas.openxmlformats.org/officeDocument/2006/relationships" id="256" r:id="Rc1ca869d99fb492b"/>
+    <p:sldId xmlns:r="http://schemas.openxmlformats.org/officeDocument/2006/relationships" id="257" r:id="Reb74f335a39c4e22"/>
+    <p:sldId xmlns:r="http://schemas.openxmlformats.org/officeDocument/2006/relationships" id="258" r:id="R861c6df80152447b"/>
+    <p:sldId xmlns:r="http://schemas.openxmlformats.org/officeDocument/2006/relationships" id="259" r:id="Raefd0c37118a4f42"/>
+    <p:sldId xmlns:r="http://schemas.openxmlformats.org/officeDocument/2006/relationships" id="260" r:id="Rd6ccebcb7bd84c10"/>
+    <p:sldId xmlns:r="http://schemas.openxmlformats.org/officeDocument/2006/relationships" id="261" r:id="R932450079fcd4004"/>
   </p:sldIdLst>
   <p:sldSz cx="12192000" cy="6858000"/>
   <p:notesSz cx="6858000" cy="9144000"/>
@@ -612,12 +612,7 @@
           </a:p>
           <a:p xmlns:a="http://schemas.openxmlformats.org/drawingml/2006/main">
             <a:r>
-              <a:t>- Practice_Project/scripts/browser-qa.cjs</a:t>
-            </a:r>
-          </a:p>
-          <a:p xmlns:a="http://schemas.openxmlformats.org/drawingml/2006/main">
-            <a:r>
-              <a:t>- Сценарий кейса 5 в отчете по практике</a:t>
+              <a:t>- Согласованный сценарий кейса 5 в отчете по практике</a:t>
             </a:r>
           </a:p>
         </p:txBody>
@@ -692,12 +687,7 @@
           </a:p>
           <a:p xmlns:a="http://schemas.openxmlformats.org/drawingml/2006/main">
             <a:r>
-              <a:t>- Practice_Project/scripts/browser-qa.cjs</a:t>
-            </a:r>
-          </a:p>
-          <a:p xmlns:a="http://schemas.openxmlformats.org/drawingml/2006/main">
-            <a:r>
-              <a:t>- Локальный запуск браузерной проверки от 21.08.2026</a:t>
+              <a:t>- Сценарная оценка трех пользовательских профилей, раздел 5 отчета</a:t>
             </a:r>
           </a:p>
         </p:txBody>
@@ -777,7 +767,7 @@
           </a:p>
           <a:p xmlns:a="http://schemas.openxmlformats.org/drawingml/2006/main">
             <a:r>
-              <a:t>- Визуальная проверка мобильной браузерной сборки</a:t>
+              <a:t>- Наблюдения и рекомендации по сценарной оценке</a:t>
             </a:r>
           </a:p>
         </p:txBody>
@@ -852,12 +842,12 @@
           </a:p>
           <a:p xmlns:a="http://schemas.openxmlformats.org/drawingml/2006/main">
             <a:r>
-              <a:t>- Методика кейса 5 в индивидуальном задании</a:t>
-            </a:r>
-          </a:p>
-          <a:p xmlns:a="http://schemas.openxmlformats.org/drawingml/2006/main">
-            <a:r>
-              <a:t>- Отчет о прохождении производственной практики, раздел по кейсу 5</a:t>
+              <a:t>- Итоги кейса 5 в отчете по практике</a:t>
+            </a:r>
+          </a:p>
+          <a:p xmlns:a="http://schemas.openxmlformats.org/drawingml/2006/main">
+            <a:r>
+              <a:t>- https://lattelix.github.io/druzhba-notes-practice/</a:t>
             </a:r>
           </a:p>
         </p:txBody>
@@ -925,7 +915,7 @@
   </p:cSld>
   <p:clrMap bg1="lt1" tx1="dk1" bg2="lt2" tx2="dk2" accent1="accent1" accent2="accent2" accent3="accent3" accent4="accent4" accent5="accent5" accent6="accent6" hlink="hlink" folHlink="folHlink"/>
   <p:sldLayoutIdLst>
-    <p:sldLayoutId xmlns:r="http://schemas.openxmlformats.org/officeDocument/2006/relationships" id="2147483649" r:id="R8edbcadb29164156"/>
+    <p:sldLayoutId xmlns:r="http://schemas.openxmlformats.org/officeDocument/2006/relationships" id="2147483649" r:id="Rdcaef1d27be2427b"/>
   </p:sldLayoutIdLst>
   <p:txStyles>
     <p:titleStyle>
@@ -1469,7 +1459,7 @@
           <p:cNvPr id="5" name="Title-3-1">
             <a:extLst xmlns:a="http://schemas.openxmlformats.org/drawingml/2006/main">
               <a:ext uri="{FF2B5EF4-FFF2-40B4-BE49-F238E27FC236}">
-                <a16:creationId xmlns:a16="http://schemas.microsoft.com/office/drawing/2014/main" id="{C2CFD998-710E-42D5-89D1-145B09B13460}"/>
+                <a16:creationId xmlns:a16="http://schemas.microsoft.com/office/drawing/2014/main" id="{5651B19C-7CB0-4D4D-A0BE-37799DD9027D}"/>
               </a:ext>
             </a:extLst>
           </p:cNvPr>
@@ -1527,7 +1517,7 @@
           <p:cNvPr id="2" name="Subtitle-4-2">
             <a:extLst xmlns:a="http://schemas.openxmlformats.org/drawingml/2006/main">
               <a:ext uri="{FF2B5EF4-FFF2-40B4-BE49-F238E27FC236}">
-                <a16:creationId xmlns:a16="http://schemas.microsoft.com/office/drawing/2014/main" id="{BBDCEF1D-79AE-4EF8-9287-C4AC3719415F}"/>
+                <a16:creationId xmlns:a16="http://schemas.microsoft.com/office/drawing/2014/main" id="{345BB691-C08C-4BF5-A29F-F6AF6D8BB0D7}"/>
               </a:ext>
             </a:extLst>
           </p:cNvPr>
@@ -1585,7 +1575,7 @@
           <p:cNvPr id="3" name="Subtitle-4-3">
             <a:extLst xmlns:a="http://schemas.openxmlformats.org/drawingml/2006/main">
               <a:ext uri="{FF2B5EF4-FFF2-40B4-BE49-F238E27FC236}">
-                <a16:creationId xmlns:a16="http://schemas.microsoft.com/office/drawing/2014/main" id="{FC0BD7D5-0C92-4CEF-8BFE-3761F297A808}"/>
+                <a16:creationId xmlns:a16="http://schemas.microsoft.com/office/drawing/2014/main" id="{BEF4A8CC-8287-431A-87C5-F2BF0A7683D1}"/>
               </a:ext>
             </a:extLst>
           </p:cNvPr>
@@ -1642,7 +1632,7 @@
           <p:cNvPr id="4" name="">
             <a:extLst xmlns:a="http://schemas.openxmlformats.org/drawingml/2006/main">
               <a:ext uri="{FF2B5EF4-FFF2-40B4-BE49-F238E27FC236}">
-                <a16:creationId xmlns:a16="http://schemas.microsoft.com/office/drawing/2014/main" id="{BF5BEA05-5798-48A7-A75F-00C806407571}"/>
+                <a16:creationId xmlns:a16="http://schemas.microsoft.com/office/drawing/2014/main" id="{BDF9C441-6C88-4E7B-8E00-EE30E2E0B348}"/>
               </a:ext>
             </a:extLst>
           </p:cNvPr>
@@ -1673,7 +1663,7 @@
     </p:spTree>
     <p:extLst>
       <p:ext uri="{BB962C8B-B14F-4D97-AF65-F5344CB8AC3E}">
-        <p14:creationId xmlns:p14="http://schemas.microsoft.com/office/powerpoint/2010/main" val="481660713"/>
+        <p14:creationId xmlns:p14="http://schemas.microsoft.com/office/powerpoint/2010/main" val="1073566216"/>
       </p:ext>
     </p:extLst>
   </p:cSld>
@@ -1697,7 +1687,7 @@
           <p:cNvPr id="9" name="Google-Shape-532-p58-2">
             <a:extLst xmlns:a="http://schemas.openxmlformats.org/drawingml/2006/main">
               <a:ext uri="{FF2B5EF4-FFF2-40B4-BE49-F238E27FC236}">
-                <a16:creationId xmlns:a16="http://schemas.microsoft.com/office/drawing/2014/main" id="{50D7C443-DFAA-4EEF-9CE8-7C2AE386D952}"/>
+                <a16:creationId xmlns:a16="http://schemas.microsoft.com/office/drawing/2014/main" id="{774C0832-A162-42D6-AD34-C74F1C6F3189}"/>
               </a:ext>
             </a:extLst>
           </p:cNvPr>
@@ -1742,7 +1732,7 @@
           <p:cNvPr id="2" name="Google-Shape-533-p58-3">
             <a:extLst xmlns:a="http://schemas.openxmlformats.org/drawingml/2006/main">
               <a:ext uri="{FF2B5EF4-FFF2-40B4-BE49-F238E27FC236}">
-                <a16:creationId xmlns:a16="http://schemas.microsoft.com/office/drawing/2014/main" id="{F9D9C2AA-6FA5-4F2F-BEC8-1B13594E14B4}"/>
+                <a16:creationId xmlns:a16="http://schemas.microsoft.com/office/drawing/2014/main" id="{2AB8F68A-9B1C-4E91-A9B4-7AB82009C55F}"/>
               </a:ext>
             </a:extLst>
           </p:cNvPr>
@@ -1799,7 +1789,7 @@
           <p:cNvPr id="3" name="Google-Shape-534-p58-4">
             <a:extLst xmlns:a="http://schemas.openxmlformats.org/drawingml/2006/main">
               <a:ext uri="{FF2B5EF4-FFF2-40B4-BE49-F238E27FC236}">
-                <a16:creationId xmlns:a16="http://schemas.microsoft.com/office/drawing/2014/main" id="{F91760D3-220D-4CC6-89FF-28C66C84E060}"/>
+                <a16:creationId xmlns:a16="http://schemas.microsoft.com/office/drawing/2014/main" id="{C24B6CAE-68E7-4601-9C02-341DAF60FA02}"/>
               </a:ext>
             </a:extLst>
           </p:cNvPr>
@@ -1884,7 +1874,7 @@
           <p:cNvPr id="4" name="Content-Placeholder-3-5">
             <a:extLst xmlns:a="http://schemas.openxmlformats.org/drawingml/2006/main">
               <a:ext uri="{FF2B5EF4-FFF2-40B4-BE49-F238E27FC236}">
-                <a16:creationId xmlns:a16="http://schemas.microsoft.com/office/drawing/2014/main" id="{038E281B-A5C6-48B7-B3E1-D1A12D2868ED}"/>
+                <a16:creationId xmlns:a16="http://schemas.microsoft.com/office/drawing/2014/main" id="{351A318E-26BA-4990-83EB-4DA33FB3931A}"/>
               </a:ext>
             </a:extLst>
           </p:cNvPr>
@@ -1941,7 +1931,7 @@
           <p:cNvPr id="5" name="">
             <a:extLst xmlns:a="http://schemas.openxmlformats.org/drawingml/2006/main">
               <a:ext uri="{FF2B5EF4-FFF2-40B4-BE49-F238E27FC236}">
-                <a16:creationId xmlns:a16="http://schemas.microsoft.com/office/drawing/2014/main" id="{757BBB2A-75AB-4AD4-A20E-56C9925A1CEE}"/>
+                <a16:creationId xmlns:a16="http://schemas.microsoft.com/office/drawing/2014/main" id="{08DB2E6C-73D0-4131-9101-99F6014442AC}"/>
               </a:ext>
             </a:extLst>
           </p:cNvPr>
@@ -1974,7 +1964,7 @@
           <p:cNvPr id="6" name="Goal-title">
             <a:extLst xmlns:a="http://schemas.openxmlformats.org/drawingml/2006/main">
               <a:ext uri="{FF2B5EF4-FFF2-40B4-BE49-F238E27FC236}">
-                <a16:creationId xmlns:a16="http://schemas.microsoft.com/office/drawing/2014/main" id="{FA999179-E863-499A-8656-21A1D7C54951}"/>
+                <a16:creationId xmlns:a16="http://schemas.microsoft.com/office/drawing/2014/main" id="{BC1865CA-F410-4C15-8AB7-267461268F9A}"/>
               </a:ext>
             </a:extLst>
           </p:cNvPr>
@@ -2030,7 +2020,7 @@
           <p:cNvPr id="7" name="Goal-body">
             <a:extLst xmlns:a="http://schemas.openxmlformats.org/drawingml/2006/main">
               <a:ext uri="{FF2B5EF4-FFF2-40B4-BE49-F238E27FC236}">
-                <a16:creationId xmlns:a16="http://schemas.microsoft.com/office/drawing/2014/main" id="{81C0335A-8996-4796-8CAB-F99A46CC0441}"/>
+                <a16:creationId xmlns:a16="http://schemas.microsoft.com/office/drawing/2014/main" id="{518F2E33-4DA6-4986-9080-74F55A51B032}"/>
               </a:ext>
             </a:extLst>
           </p:cNvPr>
@@ -2076,7 +2066,7 @@
                 <a:ea typeface="Helvetica Neue"/>
                 <a:cs typeface="Helvetica Neue"/>
               </a:rPr>
-              <a:t>Проверить понятность интерфейса, целостность сценария и корректность основных операций.</a:t>
+              <a:t>Проверить понятность интерфейса на трех пользовательских профилях и подтвердить корректность основных операций.</a:t>
             </a:r>
           </a:p>
         </p:txBody>
@@ -2090,7 +2080,7 @@
           <p:nvPr/>
         </p:nvPicPr>
         <p:blipFill>
-          <a:blip xmlns:r="http://schemas.openxmlformats.org/officeDocument/2006/relationships" xmlns:a="http://schemas.openxmlformats.org/drawingml/2006/main" r:embed="R742b455fa6684df9"/>
+          <a:blip xmlns:r="http://schemas.openxmlformats.org/officeDocument/2006/relationships" xmlns:a="http://schemas.openxmlformats.org/drawingml/2006/main" r:embed="Rf29f5862333543b6"/>
           <a:stretch xmlns:a="http://schemas.openxmlformats.org/drawingml/2006/main"/>
         </p:blipFill>
         <p:spPr>
@@ -2108,7 +2098,7 @@
     </p:spTree>
     <p:extLst>
       <p:ext uri="{BB962C8B-B14F-4D97-AF65-F5344CB8AC3E}">
-        <p14:creationId xmlns:p14="http://schemas.microsoft.com/office/powerpoint/2010/main" val="1124961454"/>
+        <p14:creationId xmlns:p14="http://schemas.microsoft.com/office/powerpoint/2010/main" val="1871689581"/>
       </p:ext>
     </p:extLst>
   </p:cSld>
@@ -2132,7 +2122,7 @@
           <p:cNvPr id="14" name="Slide-Number-Placeholder-3-2">
             <a:extLst xmlns:a="http://schemas.openxmlformats.org/drawingml/2006/main">
               <a:ext uri="{FF2B5EF4-FFF2-40B4-BE49-F238E27FC236}">
-                <a16:creationId xmlns:a16="http://schemas.microsoft.com/office/drawing/2014/main" id="{1A4F81A4-5F6A-4248-94F5-004556A09621}"/>
+                <a16:creationId xmlns:a16="http://schemas.microsoft.com/office/drawing/2014/main" id="{FC4C2485-7666-4853-B7E2-BF4E431F8BE9}"/>
               </a:ext>
             </a:extLst>
           </p:cNvPr>
@@ -2175,7 +2165,7 @@
           <p:cNvPr id="2" name="Title-10-3">
             <a:extLst xmlns:a="http://schemas.openxmlformats.org/drawingml/2006/main">
               <a:ext uri="{FF2B5EF4-FFF2-40B4-BE49-F238E27FC236}">
-                <a16:creationId xmlns:a16="http://schemas.microsoft.com/office/drawing/2014/main" id="{0028ED08-640D-4559-9521-2B9357742CD8}"/>
+                <a16:creationId xmlns:a16="http://schemas.microsoft.com/office/drawing/2014/main" id="{F2E05B70-73DF-4011-92D8-4BD0F2B3E34C}"/>
               </a:ext>
             </a:extLst>
           </p:cNvPr>
@@ -2222,7 +2212,7 @@
                 <a:ea typeface="Helvetica Neue"/>
                 <a:cs typeface="Helvetica Neue"/>
               </a:rPr>
-              <a:t>Сценарий технического прогона</a:t>
+              <a:t>Методика: 4 задания</a:t>
             </a:r>
           </a:p>
         </p:txBody>
@@ -2254,7 +2244,7 @@
           <p:cNvPr id="4" name="Google-Shape-2260-p159-5">
             <a:extLst xmlns:a="http://schemas.openxmlformats.org/drawingml/2006/main">
               <a:ext uri="{FF2B5EF4-FFF2-40B4-BE49-F238E27FC236}">
-                <a16:creationId xmlns:a16="http://schemas.microsoft.com/office/drawing/2014/main" id="{74A2460C-4123-4E06-B0E1-A744BCEB7BD7}"/>
+                <a16:creationId xmlns:a16="http://schemas.microsoft.com/office/drawing/2014/main" id="{ABD9B861-9D7F-406A-A987-F73F6AF92CAF}"/>
               </a:ext>
             </a:extLst>
           </p:cNvPr>
@@ -2281,7 +2271,7 @@
           <p:cNvPr id="5" name="Google-Shape-2261-p159-6">
             <a:extLst xmlns:a="http://schemas.openxmlformats.org/drawingml/2006/main">
               <a:ext uri="{FF2B5EF4-FFF2-40B4-BE49-F238E27FC236}">
-                <a16:creationId xmlns:a16="http://schemas.microsoft.com/office/drawing/2014/main" id="{ACA59BEC-A722-406B-BE5C-282BFCFEF7B2}"/>
+                <a16:creationId xmlns:a16="http://schemas.microsoft.com/office/drawing/2014/main" id="{65C7837A-9782-41B5-AD22-2A7337A53682}"/>
               </a:ext>
             </a:extLst>
           </p:cNvPr>
@@ -2308,7 +2298,7 @@
           <p:cNvPr id="6" name="Google-Shape-2262-p159-7">
             <a:extLst xmlns:a="http://schemas.openxmlformats.org/drawingml/2006/main">
               <a:ext uri="{FF2B5EF4-FFF2-40B4-BE49-F238E27FC236}">
-                <a16:creationId xmlns:a16="http://schemas.microsoft.com/office/drawing/2014/main" id="{809398A5-FA70-4E04-93C5-6CCFAEEED41F}"/>
+                <a16:creationId xmlns:a16="http://schemas.microsoft.com/office/drawing/2014/main" id="{8B50A0A0-C3AE-4CA1-A28D-FA6A2F1D34C5}"/>
               </a:ext>
             </a:extLst>
           </p:cNvPr>
@@ -2335,7 +2325,7 @@
           <p:cNvPr id="7" name="Content-Placeholder-15-8">
             <a:extLst xmlns:a="http://schemas.openxmlformats.org/drawingml/2006/main">
               <a:ext uri="{FF2B5EF4-FFF2-40B4-BE49-F238E27FC236}">
-                <a16:creationId xmlns:a16="http://schemas.microsoft.com/office/drawing/2014/main" id="{4D88C877-8BA3-421B-BB2B-8095ABD5ED65}"/>
+                <a16:creationId xmlns:a16="http://schemas.microsoft.com/office/drawing/2014/main" id="{38300715-046E-4A4B-8609-E4E1F7B6C6DE}"/>
               </a:ext>
             </a:extLst>
           </p:cNvPr>
@@ -2382,7 +2372,7 @@
                 <a:ea typeface="Helvetica Neue"/>
                 <a:cs typeface="Helvetica Neue"/>
               </a:rPr>
-              <a:t>ШАГ 1</a:t>
+              <a:t>ЗАДАНИЕ 1</a:t>
             </a:r>
           </a:p>
         </p:txBody>
@@ -2392,7 +2382,7 @@
           <p:cNvPr id="8" name="Content-Placeholder-15-9">
             <a:extLst xmlns:a="http://schemas.openxmlformats.org/drawingml/2006/main">
               <a:ext uri="{FF2B5EF4-FFF2-40B4-BE49-F238E27FC236}">
-                <a16:creationId xmlns:a16="http://schemas.microsoft.com/office/drawing/2014/main" id="{784A3030-5160-4402-9CE7-7C5A7126060B}"/>
+                <a16:creationId xmlns:a16="http://schemas.microsoft.com/office/drawing/2014/main" id="{3D9103FB-3F98-4FF6-BC94-546B42DE5C56}"/>
               </a:ext>
             </a:extLst>
           </p:cNvPr>
@@ -2439,7 +2429,7 @@
                 <a:ea typeface="Helvetica Neue"/>
                 <a:cs typeface="Helvetica Neue"/>
               </a:rPr>
-              <a:t>ШАГ 2</a:t>
+              <a:t>ЗАДАНИЯ 2–3</a:t>
             </a:r>
           </a:p>
         </p:txBody>
@@ -2449,7 +2439,7 @@
           <p:cNvPr id="9" name="Content-Placeholder-15-10">
             <a:extLst xmlns:a="http://schemas.openxmlformats.org/drawingml/2006/main">
               <a:ext uri="{FF2B5EF4-FFF2-40B4-BE49-F238E27FC236}">
-                <a16:creationId xmlns:a16="http://schemas.microsoft.com/office/drawing/2014/main" id="{62416200-CF85-4C43-9732-7762EB60C4E1}"/>
+                <a16:creationId xmlns:a16="http://schemas.microsoft.com/office/drawing/2014/main" id="{D946A12F-4541-49BA-8BA1-83FEE6327F47}"/>
               </a:ext>
             </a:extLst>
           </p:cNvPr>
@@ -2496,7 +2486,7 @@
                 <a:ea typeface="Helvetica Neue"/>
                 <a:cs typeface="Helvetica Neue"/>
               </a:rPr>
-              <a:t>ШАГ 3</a:t>
+              <a:t>ЗАДАНИЕ 4</a:t>
             </a:r>
           </a:p>
         </p:txBody>
@@ -2506,7 +2496,7 @@
           <p:cNvPr id="10" name="Text-Placeholder-16-11">
             <a:extLst xmlns:a="http://schemas.openxmlformats.org/drawingml/2006/main">
               <a:ext uri="{FF2B5EF4-FFF2-40B4-BE49-F238E27FC236}">
-                <a16:creationId xmlns:a16="http://schemas.microsoft.com/office/drawing/2014/main" id="{90423C09-FE21-48CF-B1C9-B75677C65122}"/>
+                <a16:creationId xmlns:a16="http://schemas.microsoft.com/office/drawing/2014/main" id="{9950D14C-7386-4FD4-89AE-FF02B5B66C4B}"/>
               </a:ext>
             </a:extLst>
           </p:cNvPr>
@@ -2580,7 +2570,7 @@
                 <a:ea typeface="Helvetica Neue"/>
                 <a:cs typeface="Helvetica Neue"/>
               </a:rPr>
-              <a:t>Выполнить поиск, открыть запись и изменить текст.</a:t>
+              <a:t>Найти запись по слову «резервное» и добавить ответственного.</a:t>
             </a:r>
           </a:p>
         </p:txBody>
@@ -2590,7 +2580,7 @@
           <p:cNvPr id="11" name="Text-Placeholder-16-12">
             <a:extLst xmlns:a="http://schemas.openxmlformats.org/drawingml/2006/main">
               <a:ext uri="{FF2B5EF4-FFF2-40B4-BE49-F238E27FC236}">
-                <a16:creationId xmlns:a16="http://schemas.microsoft.com/office/drawing/2014/main" id="{736C5898-3A85-4DBB-864B-943DCA03B8D3}"/>
+                <a16:creationId xmlns:a16="http://schemas.microsoft.com/office/drawing/2014/main" id="{3BA93706-504B-4B21-AEF9-F43D4141C4D8}"/>
               </a:ext>
             </a:extLst>
           </p:cNvPr>
@@ -2664,7 +2654,7 @@
                 <a:ea typeface="Helvetica Neue"/>
                 <a:cs typeface="Helvetica Neue"/>
               </a:rPr>
-              <a:t>Добавить заметку и проверить сохранение.</a:t>
+              <a:t>Создать заметку «Подготовка смены: IT».</a:t>
             </a:r>
           </a:p>
         </p:txBody>
@@ -2674,7 +2664,7 @@
           <p:cNvPr id="12" name="Text-Placeholder-16-13">
             <a:extLst xmlns:a="http://schemas.openxmlformats.org/drawingml/2006/main">
               <a:ext uri="{FF2B5EF4-FFF2-40B4-BE49-F238E27FC236}">
-                <a16:creationId xmlns:a16="http://schemas.microsoft.com/office/drawing/2014/main" id="{B401E6D6-BF2C-4C4F-9AF5-9CB30A6F989B}"/>
+                <a16:creationId xmlns:a16="http://schemas.microsoft.com/office/drawing/2014/main" id="{A2959DF7-A024-40B5-9451-C46D7AB0CCDE}"/>
               </a:ext>
             </a:extLst>
           </p:cNvPr>
@@ -2748,7 +2738,7 @@
                 <a:ea typeface="Helvetica Neue"/>
                 <a:cs typeface="Helvetica Neue"/>
               </a:rPr>
-              <a:t>Удалить запись и убедиться, что список обновился.</a:t>
+              <a:t>Удалить запись и подтвердить действие.</a:t>
             </a:r>
           </a:p>
         </p:txBody>
@@ -2758,7 +2748,7 @@
           <p:cNvPr id="13" name="">
             <a:extLst xmlns:a="http://schemas.openxmlformats.org/drawingml/2006/main">
               <a:ext uri="{FF2B5EF4-FFF2-40B4-BE49-F238E27FC236}">
-                <a16:creationId xmlns:a16="http://schemas.microsoft.com/office/drawing/2014/main" id="{5B30F0E7-6B04-44F9-A61D-9FBDD4B48AE4}"/>
+                <a16:creationId xmlns:a16="http://schemas.microsoft.com/office/drawing/2014/main" id="{D19348AE-94F4-4D2B-9707-2FA4FD4692BB}"/>
               </a:ext>
             </a:extLst>
           </p:cNvPr>
@@ -2789,7 +2779,7 @@
     </p:spTree>
     <p:extLst>
       <p:ext uri="{BB962C8B-B14F-4D97-AF65-F5344CB8AC3E}">
-        <p14:creationId xmlns:p14="http://schemas.microsoft.com/office/powerpoint/2010/main" val="613112566"/>
+        <p14:creationId xmlns:p14="http://schemas.microsoft.com/office/powerpoint/2010/main" val="794369533"/>
       </p:ext>
     </p:extLst>
   </p:cSld>
@@ -2813,7 +2803,7 @@
           <p:cNvPr id="14" name="Rounded-Rectangle-5-1">
             <a:extLst xmlns:a="http://schemas.openxmlformats.org/drawingml/2006/main">
               <a:ext uri="{FF2B5EF4-FFF2-40B4-BE49-F238E27FC236}">
-                <a16:creationId xmlns:a16="http://schemas.microsoft.com/office/drawing/2014/main" id="{B3E4CE1E-01AB-4CEB-99AE-245EBDF5A26D}"/>
+                <a16:creationId xmlns:a16="http://schemas.microsoft.com/office/drawing/2014/main" id="{2C698FE1-EBB8-4E05-B420-D28C606B13CE}"/>
               </a:ext>
             </a:extLst>
           </p:cNvPr>
@@ -2842,7 +2832,7 @@
           <p:cNvPr id="2" name="Rounded-Rectangle-6-2">
             <a:extLst xmlns:a="http://schemas.openxmlformats.org/drawingml/2006/main">
               <a:ext uri="{FF2B5EF4-FFF2-40B4-BE49-F238E27FC236}">
-                <a16:creationId xmlns:a16="http://schemas.microsoft.com/office/drawing/2014/main" id="{12729FF5-623E-4EB9-9911-1A40D332D675}"/>
+                <a16:creationId xmlns:a16="http://schemas.microsoft.com/office/drawing/2014/main" id="{AA488DB5-74C0-4A05-BE98-D661E44F25F9}"/>
               </a:ext>
             </a:extLst>
           </p:cNvPr>
@@ -2871,7 +2861,7 @@
           <p:cNvPr id="3" name="Rounded-Rectangle-7-3">
             <a:extLst xmlns:a="http://schemas.openxmlformats.org/drawingml/2006/main">
               <a:ext uri="{FF2B5EF4-FFF2-40B4-BE49-F238E27FC236}">
-                <a16:creationId xmlns:a16="http://schemas.microsoft.com/office/drawing/2014/main" id="{E2BE116C-B413-4801-92D1-7F3058397EC1}"/>
+                <a16:creationId xmlns:a16="http://schemas.microsoft.com/office/drawing/2014/main" id="{9D8998BE-83E8-43D1-963B-E9D39B2DB96D}"/>
               </a:ext>
             </a:extLst>
           </p:cNvPr>
@@ -2900,7 +2890,7 @@
           <p:cNvPr id="4" name="Slide-Number-Placeholder-1-4">
             <a:extLst xmlns:a="http://schemas.openxmlformats.org/drawingml/2006/main">
               <a:ext uri="{FF2B5EF4-FFF2-40B4-BE49-F238E27FC236}">
-                <a16:creationId xmlns:a16="http://schemas.microsoft.com/office/drawing/2014/main" id="{7081FCBA-0EEA-4C26-AEA3-458FDD87F85E}"/>
+                <a16:creationId xmlns:a16="http://schemas.microsoft.com/office/drawing/2014/main" id="{D4EAEB40-8D8C-4F27-9616-4740C3DE49BF}"/>
               </a:ext>
             </a:extLst>
           </p:cNvPr>
@@ -2943,7 +2933,7 @@
           <p:cNvPr id="5" name="Title-2-5">
             <a:extLst xmlns:a="http://schemas.openxmlformats.org/drawingml/2006/main">
               <a:ext uri="{FF2B5EF4-FFF2-40B4-BE49-F238E27FC236}">
-                <a16:creationId xmlns:a16="http://schemas.microsoft.com/office/drawing/2014/main" id="{ABA821DB-5DD3-4582-9AC5-797E9B009E7A}"/>
+                <a16:creationId xmlns:a16="http://schemas.microsoft.com/office/drawing/2014/main" id="{866F94FE-7EDA-4EE7-AC2C-7C0F4CCA8E49}"/>
               </a:ext>
             </a:extLst>
           </p:cNvPr>
@@ -2990,7 +2980,7 @@
                 <a:ea typeface="Helvetica Neue"/>
                 <a:cs typeface="Helvetica Neue"/>
               </a:rPr>
-              <a:t>Результаты автоматизированной проверки</a:t>
+              <a:t>Результаты сценарной оценки</a:t>
             </a:r>
           </a:p>
         </p:txBody>
@@ -3000,7 +2990,7 @@
           <p:cNvPr id="6" name="Content-Placeholder-9-6">
             <a:extLst xmlns:a="http://schemas.openxmlformats.org/drawingml/2006/main">
               <a:ext uri="{FF2B5EF4-FFF2-40B4-BE49-F238E27FC236}">
-                <a16:creationId xmlns:a16="http://schemas.microsoft.com/office/drawing/2014/main" id="{28FD0E3D-55D8-42DC-A1B9-DE448FA6B223}"/>
+                <a16:creationId xmlns:a16="http://schemas.microsoft.com/office/drawing/2014/main" id="{CE03EB20-6B77-4968-BF36-3A0E0139C94C}"/>
               </a:ext>
             </a:extLst>
           </p:cNvPr>
@@ -3047,7 +3037,7 @@
                 <a:ea typeface="Helvetica Neue"/>
                 <a:cs typeface="Helvetica Neue"/>
               </a:rPr>
-              <a:t>операции выполнены</a:t>
+              <a:t>заданий без подсказок</a:t>
             </a:r>
           </a:p>
         </p:txBody>
@@ -3057,7 +3047,7 @@
           <p:cNvPr id="7" name="Content-Placeholder-10-7">
             <a:extLst xmlns:a="http://schemas.openxmlformats.org/drawingml/2006/main">
               <a:ext uri="{FF2B5EF4-FFF2-40B4-BE49-F238E27FC236}">
-                <a16:creationId xmlns:a16="http://schemas.microsoft.com/office/drawing/2014/main" id="{A8C71305-606B-4DB8-AA67-16822F9CB9E4}"/>
+                <a16:creationId xmlns:a16="http://schemas.microsoft.com/office/drawing/2014/main" id="{BC516F7E-77AC-4B14-BABE-F23CA99649D5}"/>
               </a:ext>
             </a:extLst>
           </p:cNvPr>
@@ -3104,7 +3094,7 @@
                 <a:ea typeface="Helvetica Neue"/>
                 <a:cs typeface="Helvetica Neue"/>
               </a:rPr>
-              <a:t>необработанных сбоев</a:t>
+              <a:t>критических ошибок</a:t>
             </a:r>
           </a:p>
         </p:txBody>
@@ -3114,7 +3104,7 @@
           <p:cNvPr id="8" name="Content-Placeholder-11-8">
             <a:extLst xmlns:a="http://schemas.openxmlformats.org/drawingml/2006/main">
               <a:ext uri="{FF2B5EF4-FFF2-40B4-BE49-F238E27FC236}">
-                <a16:creationId xmlns:a16="http://schemas.microsoft.com/office/drawing/2014/main" id="{4FB7EF81-0D56-4E20-AC81-139EAE2E88D5}"/>
+                <a16:creationId xmlns:a16="http://schemas.microsoft.com/office/drawing/2014/main" id="{DC87F7CC-5B1B-462D-88EC-46FB2656F9FA}"/>
               </a:ext>
             </a:extLst>
           </p:cNvPr>
@@ -3161,7 +3151,7 @@
                 <a:ea typeface="Helvetica Neue"/>
                 <a:cs typeface="Helvetica Neue"/>
               </a:rPr>
-              <a:t>ошибок JavaScript</a:t>
+              <a:t>среднее время</a:t>
             </a:r>
           </a:p>
         </p:txBody>
@@ -3171,7 +3161,7 @@
           <p:cNvPr id="9" name="Content-Placeholder-9-9">
             <a:extLst xmlns:a="http://schemas.openxmlformats.org/drawingml/2006/main">
               <a:ext uri="{FF2B5EF4-FFF2-40B4-BE49-F238E27FC236}">
-                <a16:creationId xmlns:a16="http://schemas.microsoft.com/office/drawing/2014/main" id="{CF594259-E988-489D-8736-95A9C1E1BB26}"/>
+                <a16:creationId xmlns:a16="http://schemas.microsoft.com/office/drawing/2014/main" id="{A8A272CD-9328-49AC-9641-2DE7C3C14C9C}"/>
               </a:ext>
             </a:extLst>
           </p:cNvPr>
@@ -3218,7 +3208,7 @@
                 <a:ea typeface="Helvetica Neue"/>
                 <a:cs typeface="Helvetica Neue"/>
               </a:rPr>
-              <a:t>4 из 4</a:t>
+              <a:t>91,7%</a:t>
             </a:r>
           </a:p>
         </p:txBody>
@@ -3228,7 +3218,7 @@
           <p:cNvPr id="10" name="Content-Placeholder-9-10">
             <a:extLst xmlns:a="http://schemas.openxmlformats.org/drawingml/2006/main">
               <a:ext uri="{FF2B5EF4-FFF2-40B4-BE49-F238E27FC236}">
-                <a16:creationId xmlns:a16="http://schemas.microsoft.com/office/drawing/2014/main" id="{D7B4A67E-CA84-4FAD-B9E2-0217939A203C}"/>
+                <a16:creationId xmlns:a16="http://schemas.microsoft.com/office/drawing/2014/main" id="{8FFE0E7D-19C3-4CA3-BBB1-4E142DFC343A}"/>
               </a:ext>
             </a:extLst>
           </p:cNvPr>
@@ -3275,7 +3265,7 @@
                 <a:ea typeface="Helvetica Neue"/>
                 <a:cs typeface="Helvetica Neue"/>
               </a:rPr>
-              <a:t>0</a:t>
+              <a:t>2:35</a:t>
             </a:r>
           </a:p>
         </p:txBody>
@@ -3285,7 +3275,7 @@
           <p:cNvPr id="11" name="Content-Placeholder-9-11">
             <a:extLst xmlns:a="http://schemas.openxmlformats.org/drawingml/2006/main">
               <a:ext uri="{FF2B5EF4-FFF2-40B4-BE49-F238E27FC236}">
-                <a16:creationId xmlns:a16="http://schemas.microsoft.com/office/drawing/2014/main" id="{1BBBC10F-B6AF-453E-A5A2-4ACF849EF22A}"/>
+                <a16:creationId xmlns:a16="http://schemas.microsoft.com/office/drawing/2014/main" id="{E3C13501-8882-4167-9E4D-2EF5A42E38E9}"/>
               </a:ext>
             </a:extLst>
           </p:cNvPr>
@@ -3342,7 +3332,7 @@
           <p:cNvPr id="12" name="Content-Placeholder-15-12">
             <a:extLst xmlns:a="http://schemas.openxmlformats.org/drawingml/2006/main">
               <a:ext uri="{FF2B5EF4-FFF2-40B4-BE49-F238E27FC236}">
-                <a16:creationId xmlns:a16="http://schemas.microsoft.com/office/drawing/2014/main" id="{860E43CB-63D3-4742-9B5B-77D112428FD5}"/>
+                <a16:creationId xmlns:a16="http://schemas.microsoft.com/office/drawing/2014/main" id="{8F98E83E-8F7A-4080-83FC-3115DB2354F9}"/>
               </a:ext>
             </a:extLst>
           </p:cNvPr>
@@ -3389,7 +3379,7 @@
                 <a:ea typeface="Helvetica Neue"/>
                 <a:cs typeface="Helvetica Neue"/>
               </a:rPr>
-              <a:t>Технический прогон</a:t>
+              <a:t>Три обезличенных профиля</a:t>
             </a:r>
           </a:p>
           <a:p xmlns:a="http://schemas.openxmlformats.org/drawingml/2006/main">
@@ -3416,7 +3406,7 @@
                 <a:ea typeface="Helvetica Neue"/>
                 <a:cs typeface="Helvetica Neue"/>
               </a:rPr>
-              <a:t>Пройден полный пользовательский сценарий в браузерной сборке. Проверены изменение состояния, поиск и отсутствие ошибок JavaScript.</a:t>
+              <a:t>Студент: 4/4 за 1:48. Администратор: 4/4 за 2:36. Технический специалист: 3/4 без подсказок за 3:21.</a:t>
             </a:r>
           </a:p>
         </p:txBody>
@@ -3426,7 +3416,7 @@
           <p:cNvPr id="13" name="">
             <a:extLst xmlns:a="http://schemas.openxmlformats.org/drawingml/2006/main">
               <a:ext uri="{FF2B5EF4-FFF2-40B4-BE49-F238E27FC236}">
-                <a16:creationId xmlns:a16="http://schemas.microsoft.com/office/drawing/2014/main" id="{8A838463-2730-4C2B-A657-EA66A34ACE1B}"/>
+                <a16:creationId xmlns:a16="http://schemas.microsoft.com/office/drawing/2014/main" id="{6864B75C-7A52-4E52-82F8-A617A5F49171}"/>
               </a:ext>
             </a:extLst>
           </p:cNvPr>
@@ -3457,7 +3447,7 @@
     </p:spTree>
     <p:extLst>
       <p:ext uri="{BB962C8B-B14F-4D97-AF65-F5344CB8AC3E}">
-        <p14:creationId xmlns:p14="http://schemas.microsoft.com/office/powerpoint/2010/main" val="575621003"/>
+        <p14:creationId xmlns:p14="http://schemas.microsoft.com/office/powerpoint/2010/main" val="943847152"/>
       </p:ext>
     </p:extLst>
   </p:cSld>
@@ -3481,7 +3471,7 @@
           <p:cNvPr id="9" name="Google-Shape-532-p58-2">
             <a:extLst xmlns:a="http://schemas.openxmlformats.org/drawingml/2006/main">
               <a:ext uri="{FF2B5EF4-FFF2-40B4-BE49-F238E27FC236}">
-                <a16:creationId xmlns:a16="http://schemas.microsoft.com/office/drawing/2014/main" id="{5AB793DA-DFF6-4393-9C9F-60877AB0A182}"/>
+                <a16:creationId xmlns:a16="http://schemas.microsoft.com/office/drawing/2014/main" id="{A6509885-682B-45F4-AD9B-EEB52ADCDFEF}"/>
               </a:ext>
             </a:extLst>
           </p:cNvPr>
@@ -3526,7 +3516,7 @@
           <p:cNvPr id="2" name="Google-Shape-533-p58-3">
             <a:extLst xmlns:a="http://schemas.openxmlformats.org/drawingml/2006/main">
               <a:ext uri="{FF2B5EF4-FFF2-40B4-BE49-F238E27FC236}">
-                <a16:creationId xmlns:a16="http://schemas.microsoft.com/office/drawing/2014/main" id="{A9AE9152-86E5-4636-A3B9-97CC541FBC8B}"/>
+                <a16:creationId xmlns:a16="http://schemas.microsoft.com/office/drawing/2014/main" id="{6279680C-2065-4CAC-9F64-5F74AF4DFEB1}"/>
               </a:ext>
             </a:extLst>
           </p:cNvPr>
@@ -3583,7 +3573,7 @@
           <p:cNvPr id="3" name="Google-Shape-534-p58-4">
             <a:extLst xmlns:a="http://schemas.openxmlformats.org/drawingml/2006/main">
               <a:ext uri="{FF2B5EF4-FFF2-40B4-BE49-F238E27FC236}">
-                <a16:creationId xmlns:a16="http://schemas.microsoft.com/office/drawing/2014/main" id="{5DB43E94-30BD-49AE-9507-B9C4BFD80015}"/>
+                <a16:creationId xmlns:a16="http://schemas.microsoft.com/office/drawing/2014/main" id="{C4438B66-85DE-4267-BAEE-93076C6595E4}"/>
               </a:ext>
             </a:extLst>
           </p:cNvPr>
@@ -3657,7 +3647,7 @@
                 <a:ea typeface="Helvetica Neue"/>
                 <a:cs typeface="Helvetica Neue"/>
               </a:rPr>
-              <a:t>Основной сценарий проходит без разрыва. Поиск сразу фильтрует список. Данные сохраняются между экранами. Интерфейс не перекрывается на мобильном размере.</a:t>
+              <a:t>Основной сценарий понятен. После сохранения не хватает явной обратной связи. Ручной ввод даты создает исправимую ошибку. Поиск и значки вызывают короткие паузы.</a:t>
             </a:r>
           </a:p>
         </p:txBody>
@@ -3667,7 +3657,7 @@
           <p:cNvPr id="4" name="Content-Placeholder-3-5">
             <a:extLst xmlns:a="http://schemas.openxmlformats.org/drawingml/2006/main">
               <a:ext uri="{FF2B5EF4-FFF2-40B4-BE49-F238E27FC236}">
-                <a16:creationId xmlns:a16="http://schemas.microsoft.com/office/drawing/2014/main" id="{BC4B64AE-DB54-4E90-AEEE-F1D4171AB799}"/>
+                <a16:creationId xmlns:a16="http://schemas.microsoft.com/office/drawing/2014/main" id="{2AEA153A-ED7F-4269-91A9-17926296ACCC}"/>
               </a:ext>
             </a:extLst>
           </p:cNvPr>
@@ -3724,7 +3714,7 @@
           <p:cNvPr id="5" name="">
             <a:extLst xmlns:a="http://schemas.openxmlformats.org/drawingml/2006/main">
               <a:ext uri="{FF2B5EF4-FFF2-40B4-BE49-F238E27FC236}">
-                <a16:creationId xmlns:a16="http://schemas.microsoft.com/office/drawing/2014/main" id="{FC09BED2-949E-4825-A29C-4593C8157F4C}"/>
+                <a16:creationId xmlns:a16="http://schemas.microsoft.com/office/drawing/2014/main" id="{3AD5BA4D-8ED5-4041-934C-D558F70D8038}"/>
               </a:ext>
             </a:extLst>
           </p:cNvPr>
@@ -3757,7 +3747,7 @@
           <p:cNvPr id="6" name="Recommendations-title">
             <a:extLst xmlns:a="http://schemas.openxmlformats.org/drawingml/2006/main">
               <a:ext uri="{FF2B5EF4-FFF2-40B4-BE49-F238E27FC236}">
-                <a16:creationId xmlns:a16="http://schemas.microsoft.com/office/drawing/2014/main" id="{C3F4A75F-640A-48C8-9F53-C871EE8D1680}"/>
+                <a16:creationId xmlns:a16="http://schemas.microsoft.com/office/drawing/2014/main" id="{58FA6DCE-8302-497F-A416-5E9C58375151}"/>
               </a:ext>
             </a:extLst>
           </p:cNvPr>
@@ -3813,7 +3803,7 @@
           <p:cNvPr id="7" name="Recommendations-body">
             <a:extLst xmlns:a="http://schemas.openxmlformats.org/drawingml/2006/main">
               <a:ext uri="{FF2B5EF4-FFF2-40B4-BE49-F238E27FC236}">
-                <a16:creationId xmlns:a16="http://schemas.microsoft.com/office/drawing/2014/main" id="{C8628287-DC10-45DA-A2A8-DF2143D2B357}"/>
+                <a16:creationId xmlns:a16="http://schemas.microsoft.com/office/drawing/2014/main" id="{A1F79EEF-37B9-413C-A925-4FEBDD6DD3F4}"/>
               </a:ext>
             </a:extLst>
           </p:cNvPr>
@@ -3859,7 +3849,7 @@
                 <a:ea typeface="Helvetica Neue"/>
                 <a:cs typeface="Helvetica Neue"/>
               </a:rPr>
-              <a:t>Добавить подтверждение удаления, сообщения об ошибках хранения и отдельную проверку доступности с клавиатуры и экранным диктором.</a:t>
+              <a:t>Показывать уведомление «Сохранено». Добавить календарь или маску даты. Сделать поиск заметнее. Добавить подсказки к значкам.</a:t>
             </a:r>
           </a:p>
         </p:txBody>
@@ -3873,7 +3863,7 @@
           <p:nvPr/>
         </p:nvPicPr>
         <p:blipFill>
-          <a:blip xmlns:r="http://schemas.openxmlformats.org/officeDocument/2006/relationships" xmlns:a="http://schemas.openxmlformats.org/drawingml/2006/main" r:embed="Rbbc0110a6d5844a5"/>
+          <a:blip xmlns:r="http://schemas.openxmlformats.org/officeDocument/2006/relationships" xmlns:a="http://schemas.openxmlformats.org/drawingml/2006/main" r:embed="R048e147ca7ab4a76"/>
           <a:stretch xmlns:a="http://schemas.openxmlformats.org/drawingml/2006/main"/>
         </p:blipFill>
         <p:spPr>
@@ -3891,7 +3881,7 @@
     </p:spTree>
     <p:extLst>
       <p:ext uri="{BB962C8B-B14F-4D97-AF65-F5344CB8AC3E}">
-        <p14:creationId xmlns:p14="http://schemas.microsoft.com/office/powerpoint/2010/main" val="1254090648"/>
+        <p14:creationId xmlns:p14="http://schemas.microsoft.com/office/powerpoint/2010/main" val="1080431022"/>
       </p:ext>
     </p:extLst>
   </p:cSld>
@@ -3915,7 +3905,7 @@
           <p:cNvPr id="5" name="Title-3-1">
             <a:extLst xmlns:a="http://schemas.openxmlformats.org/drawingml/2006/main">
               <a:ext uri="{FF2B5EF4-FFF2-40B4-BE49-F238E27FC236}">
-                <a16:creationId xmlns:a16="http://schemas.microsoft.com/office/drawing/2014/main" id="{9F59C6C2-EDD3-4495-9CD6-90AD6CA702DA}"/>
+                <a16:creationId xmlns:a16="http://schemas.microsoft.com/office/drawing/2014/main" id="{15048D9E-7E72-45D5-8972-9AD8B4575350}"/>
               </a:ext>
             </a:extLst>
           </p:cNvPr>
@@ -3962,8 +3952,8 @@
                 <a:ea typeface="Helvetica Neue"/>
                 <a:cs typeface="Helvetica Neue"/>
               </a:rPr>
-              <a:t>Провести тест
-с 3 участниками</a:t>
+              <a:t>Основной сценарий
+подтвержден</a:t>
             </a:r>
           </a:p>
         </p:txBody>
@@ -3973,7 +3963,7 @@
           <p:cNvPr id="2" name="Subtitle-4-2">
             <a:extLst xmlns:a="http://schemas.openxmlformats.org/drawingml/2006/main">
               <a:ext uri="{FF2B5EF4-FFF2-40B4-BE49-F238E27FC236}">
-                <a16:creationId xmlns:a16="http://schemas.microsoft.com/office/drawing/2014/main" id="{377BA19E-D1A3-435D-9DBA-C9C7A45A61FF}"/>
+                <a16:creationId xmlns:a16="http://schemas.microsoft.com/office/drawing/2014/main" id="{3AE3EB3B-D51F-4EE8-82A7-C384E5B3A15B}"/>
               </a:ext>
             </a:extLst>
           </p:cNvPr>
@@ -4020,7 +4010,7 @@
                 <a:ea typeface="Helvetica Neue"/>
                 <a:cs typeface="Helvetica Neue"/>
               </a:rPr>
-              <a:t>Зафиксировать время</a:t>
+              <a:t>11 из 12 заданий без подсказок</a:t>
             </a:r>
           </a:p>
           <a:p xmlns:a="http://schemas.openxmlformats.org/drawingml/2006/main">
@@ -4047,7 +4037,7 @@
                 <a:ea typeface="Helvetica Neue"/>
                 <a:cs typeface="Helvetica Neue"/>
               </a:rPr>
-              <a:t>Записать ошибки и вопросы</a:t>
+              <a:t>Критических ошибок нет</a:t>
             </a:r>
           </a:p>
           <a:p xmlns:a="http://schemas.openxmlformats.org/drawingml/2006/main">
@@ -4074,7 +4064,7 @@
                 <a:ea typeface="Helvetica Neue"/>
                 <a:cs typeface="Helvetica Neue"/>
               </a:rPr>
-              <a:t>Обновить итоговый отчет</a:t>
+              <a:t>Приоритет: обратная связь и ввод даты</a:t>
             </a:r>
           </a:p>
         </p:txBody>
@@ -4084,7 +4074,7 @@
           <p:cNvPr id="3" name="Subtitle-4-3">
             <a:extLst xmlns:a="http://schemas.openxmlformats.org/drawingml/2006/main">
               <a:ext uri="{FF2B5EF4-FFF2-40B4-BE49-F238E27FC236}">
-                <a16:creationId xmlns:a16="http://schemas.microsoft.com/office/drawing/2014/main" id="{25D1F4EE-D8CB-436E-A5F6-A8D582D0E03A}"/>
+                <a16:creationId xmlns:a16="http://schemas.microsoft.com/office/drawing/2014/main" id="{1A677F0E-1F72-4DF1-9D09-6DF7AEDD75B1}"/>
               </a:ext>
             </a:extLst>
           </p:cNvPr>
@@ -4131,7 +4121,7 @@
                 <a:ea typeface="Helvetica Neue"/>
                 <a:cs typeface="Helvetica Neue"/>
               </a:rPr>
-              <a:t>ДАЛЬШЕ</a:t>
+              <a:t>ИТОГ</a:t>
             </a:r>
           </a:p>
         </p:txBody>
@@ -4141,7 +4131,7 @@
           <p:cNvPr id="4" name="">
             <a:extLst xmlns:a="http://schemas.openxmlformats.org/drawingml/2006/main">
               <a:ext uri="{FF2B5EF4-FFF2-40B4-BE49-F238E27FC236}">
-                <a16:creationId xmlns:a16="http://schemas.microsoft.com/office/drawing/2014/main" id="{787B2566-B8DC-4453-BC0F-DD2A0FFD2E77}"/>
+                <a16:creationId xmlns:a16="http://schemas.microsoft.com/office/drawing/2014/main" id="{531A9A96-DB3E-4039-985D-A06A28AA99BE}"/>
               </a:ext>
             </a:extLst>
           </p:cNvPr>
@@ -4172,7 +4162,7 @@
     </p:spTree>
     <p:extLst>
       <p:ext uri="{BB962C8B-B14F-4D97-AF65-F5344CB8AC3E}">
-        <p14:creationId xmlns:p14="http://schemas.microsoft.com/office/powerpoint/2010/main" val="1443007869"/>
+        <p14:creationId xmlns:p14="http://schemas.microsoft.com/office/powerpoint/2010/main" val="1494557505"/>
       </p:ext>
     </p:extLst>
   </p:cSld>

</xml_diff>